<commit_message>
Publish actual CLI demo, reproducible capture and final eight-slide pitch
</commit_message>
<xml_diff>
--- a/docs/EvidenceDesk-pitch.pptx
+++ b/docs/EvidenceDesk-pitch.pptx
@@ -2,20 +2,20 @@
 <file path=ppt/presentation.xml><?xml version="1.0" encoding="utf-8"?>
 <p:presentation xmlns:p="http://schemas.openxmlformats.org/presentationml/2006/main">
   <p:sldMasterIdLst>
-    <p:sldMasterId xmlns:r="http://schemas.openxmlformats.org/officeDocument/2006/relationships" id="2147483648" r:id="R18b639cfddbd4605"/>
+    <p:sldMasterId xmlns:r="http://schemas.openxmlformats.org/officeDocument/2006/relationships" id="2147483648" r:id="R9dd9eb8d2f134730"/>
   </p:sldMasterIdLst>
   <p:notesMasterIdLst>
-    <p:notesMasterId xmlns:r="http://schemas.openxmlformats.org/officeDocument/2006/relationships" r:id="Rf2ac9f4f5f9947f4"/>
+    <p:notesMasterId xmlns:r="http://schemas.openxmlformats.org/officeDocument/2006/relationships" r:id="R8f6130c8b5d84555"/>
   </p:notesMasterIdLst>
   <p:sldIdLst>
-    <p:sldId xmlns:r="http://schemas.openxmlformats.org/officeDocument/2006/relationships" id="256" r:id="R1e0aedff2c9f4e57"/>
-    <p:sldId xmlns:r="http://schemas.openxmlformats.org/officeDocument/2006/relationships" id="257" r:id="R2c51f4841518422b"/>
-    <p:sldId xmlns:r="http://schemas.openxmlformats.org/officeDocument/2006/relationships" id="258" r:id="Rd32eb2f909c64d37"/>
-    <p:sldId xmlns:r="http://schemas.openxmlformats.org/officeDocument/2006/relationships" id="259" r:id="R80b7153086144b8e"/>
-    <p:sldId xmlns:r="http://schemas.openxmlformats.org/officeDocument/2006/relationships" id="260" r:id="R158736c63d3143f2"/>
-    <p:sldId xmlns:r="http://schemas.openxmlformats.org/officeDocument/2006/relationships" id="261" r:id="Rb6e0057e513b4283"/>
-    <p:sldId xmlns:r="http://schemas.openxmlformats.org/officeDocument/2006/relationships" id="262" r:id="R0ea2c0285d40444a"/>
-    <p:sldId xmlns:r="http://schemas.openxmlformats.org/officeDocument/2006/relationships" id="263" r:id="Ra34b6a42c1d04ac8"/>
+    <p:sldId xmlns:r="http://schemas.openxmlformats.org/officeDocument/2006/relationships" id="256" r:id="R54dac8035dfd4875"/>
+    <p:sldId xmlns:r="http://schemas.openxmlformats.org/officeDocument/2006/relationships" id="257" r:id="Rf60bfa0729dc4dc9"/>
+    <p:sldId xmlns:r="http://schemas.openxmlformats.org/officeDocument/2006/relationships" id="258" r:id="Rd62f030d60d84583"/>
+    <p:sldId xmlns:r="http://schemas.openxmlformats.org/officeDocument/2006/relationships" id="259" r:id="Rdac65cf31a314630"/>
+    <p:sldId xmlns:r="http://schemas.openxmlformats.org/officeDocument/2006/relationships" id="260" r:id="R688239f47edf47b5"/>
+    <p:sldId xmlns:r="http://schemas.openxmlformats.org/officeDocument/2006/relationships" id="261" r:id="Rd380593a8ee44e87"/>
+    <p:sldId xmlns:r="http://schemas.openxmlformats.org/officeDocument/2006/relationships" id="262" r:id="R48a9a713cf2d4791"/>
+    <p:sldId xmlns:r="http://schemas.openxmlformats.org/officeDocument/2006/relationships" id="263" r:id="R12e814c21a2040b1"/>
   </p:sldIdLst>
   <p:sldSz cx="12192000" cy="6858000"/>
   <p:notesSz cx="6858000" cy="9144000"/>
@@ -939,7 +939,7 @@
           <a:lstStyle xmlns:a="http://schemas.openxmlformats.org/drawingml/2006/main"/>
           <a:p xmlns:a="http://schemas.openxmlformats.org/drawingml/2006/main">
             <a:r>
-              <a:t>Sources: submission-pack.md and current-status.md plus parent-verified publication update on 11 September 2026. Public repository: https://github.com/alexsolonsky/evidencedesk at commit 96fa0abeac84f82e01e2b2403a24e9bfa0adb7a3. Parent reports a fresh unauthenticated clone and a 44-file manifest verification passed (45 files including manifest). An actual CLI demonstration is being prepared; a recorded demo is still pending. Evaluation rows remain planned work. No deployment, time saving, user adoption or general accuracy claim.</a:t>
+              <a:t>Sources: submission-pack.md and current-status.md plus parent-verified publication update on 11 September 2026. Public repository: https://github.com/alexsolonsky/evidencedesk at commit 96fa0abeac84f82e01e2b2403a24e9bfa0adb7a3. Parent reports a fresh unauthenticated clone and a 44-file manifest verification passed (45 files including manifest). Parent reports a verified 3:40 actual CLI demonstration is complete, with an actual qwen run. CLI demo: https://github.com/alexsolonsky/evidencedesk/blob/main/demo/evidencedesk-cli-demo.mp4 . Browser UI recording remains pending. This deck subagent did not independently review the demonstration. Evaluation rows remain planned work. No deployment, time saving, user adoption or general accuracy claim.</a:t>
             </a:r>
           </a:p>
         </p:txBody>
@@ -1007,7 +1007,7 @@
   </p:cSld>
   <p:clrMap bg1="lt1" tx1="dk1" bg2="lt2" tx2="dk2" accent1="accent1" accent2="accent2" accent3="accent3" accent4="accent4" accent5="accent5" accent6="accent6" hlink="hlink" folHlink="folHlink"/>
   <p:sldLayoutIdLst>
-    <p:sldLayoutId xmlns:r="http://schemas.openxmlformats.org/officeDocument/2006/relationships" id="2147483649" r:id="Rf68d2860242a4880"/>
+    <p:sldLayoutId xmlns:r="http://schemas.openxmlformats.org/officeDocument/2006/relationships" id="2147483649" r:id="Rc4c77405a868413b"/>
   </p:sldLayoutIdLst>
   <p:txStyles>
     <p:titleStyle>
@@ -1558,7 +1558,7 @@
           <p:cNvPr id="5" name="">
             <a:extLst xmlns:a="http://schemas.openxmlformats.org/drawingml/2006/main">
               <a:ext uri="{FF2B5EF4-FFF2-40B4-BE49-F238E27FC236}">
-                <a16:creationId xmlns:a16="http://schemas.microsoft.com/office/drawing/2014/main" id="{A268B87B-53C7-46C2-9BE8-BA1CF5F5A322}"/>
+                <a16:creationId xmlns:a16="http://schemas.microsoft.com/office/drawing/2014/main" id="{F9AE887E-3804-4C80-8C8B-522289ABEAA7}"/>
               </a:ext>
             </a:extLst>
           </p:cNvPr>
@@ -1615,7 +1615,7 @@
           <p:cNvPr id="2" name="">
             <a:extLst xmlns:a="http://schemas.openxmlformats.org/drawingml/2006/main">
               <a:ext uri="{FF2B5EF4-FFF2-40B4-BE49-F238E27FC236}">
-                <a16:creationId xmlns:a16="http://schemas.microsoft.com/office/drawing/2014/main" id="{D9289B1F-C395-4860-9A71-F33BAE04E3D0}"/>
+                <a16:creationId xmlns:a16="http://schemas.microsoft.com/office/drawing/2014/main" id="{8130510E-C58B-499F-9D80-2D43C1CB6E13}"/>
               </a:ext>
             </a:extLst>
           </p:cNvPr>
@@ -1695,7 +1695,7 @@
           <p:cNvPr id="3" name="">
             <a:extLst xmlns:a="http://schemas.openxmlformats.org/drawingml/2006/main">
               <a:ext uri="{FF2B5EF4-FFF2-40B4-BE49-F238E27FC236}">
-                <a16:creationId xmlns:a16="http://schemas.microsoft.com/office/drawing/2014/main" id="{DF89674C-AC99-4D93-8CEF-52240EF20861}"/>
+                <a16:creationId xmlns:a16="http://schemas.microsoft.com/office/drawing/2014/main" id="{0281AD03-AB1B-49F3-A348-059E60071198}"/>
               </a:ext>
             </a:extLst>
           </p:cNvPr>
@@ -1752,7 +1752,7 @@
           <p:cNvPr id="4" name="">
             <a:extLst xmlns:a="http://schemas.openxmlformats.org/drawingml/2006/main">
               <a:ext uri="{FF2B5EF4-FFF2-40B4-BE49-F238E27FC236}">
-                <a16:creationId xmlns:a16="http://schemas.microsoft.com/office/drawing/2014/main" id="{1272D645-1781-4D51-9CA3-B2EB12F225D6}"/>
+                <a16:creationId xmlns:a16="http://schemas.microsoft.com/office/drawing/2014/main" id="{55F964CF-818C-4BB7-A362-E2D85750FBC8}"/>
               </a:ext>
             </a:extLst>
           </p:cNvPr>
@@ -1807,7 +1807,7 @@
     </p:spTree>
     <p:extLst>
       <p:ext uri="{BB962C8B-B14F-4D97-AF65-F5344CB8AC3E}">
-        <p14:creationId xmlns:p14="http://schemas.microsoft.com/office/powerpoint/2010/main" val="1604757425"/>
+        <p14:creationId xmlns:p14="http://schemas.microsoft.com/office/powerpoint/2010/main" val="571775203"/>
       </p:ext>
     </p:extLst>
   </p:cSld>
@@ -1838,7 +1838,7 @@
           <p:cNvPr id="9" name="">
             <a:extLst xmlns:a="http://schemas.openxmlformats.org/drawingml/2006/main">
               <a:ext uri="{FF2B5EF4-FFF2-40B4-BE49-F238E27FC236}">
-                <a16:creationId xmlns:a16="http://schemas.microsoft.com/office/drawing/2014/main" id="{78EABBD7-78E4-46A1-82BB-AB05B1EBE21C}"/>
+                <a16:creationId xmlns:a16="http://schemas.microsoft.com/office/drawing/2014/main" id="{E16CCD44-3A4C-4C16-B688-875B8F78A0D6}"/>
               </a:ext>
             </a:extLst>
           </p:cNvPr>
@@ -1895,7 +1895,7 @@
           <p:cNvPr id="2" name="">
             <a:extLst xmlns:a="http://schemas.openxmlformats.org/drawingml/2006/main">
               <a:ext uri="{FF2B5EF4-FFF2-40B4-BE49-F238E27FC236}">
-                <a16:creationId xmlns:a16="http://schemas.microsoft.com/office/drawing/2014/main" id="{CAE31415-D66A-4F0D-AAC0-A1FB1B47104F}"/>
+                <a16:creationId xmlns:a16="http://schemas.microsoft.com/office/drawing/2014/main" id="{4A712F1C-2CBB-4BD3-B9B9-1F6770DAB7D1}"/>
               </a:ext>
             </a:extLst>
           </p:cNvPr>
@@ -1952,7 +1952,7 @@
           <p:cNvPr id="3" name="">
             <a:extLst xmlns:a="http://schemas.openxmlformats.org/drawingml/2006/main">
               <a:ext uri="{FF2B5EF4-FFF2-40B4-BE49-F238E27FC236}">
-                <a16:creationId xmlns:a16="http://schemas.microsoft.com/office/drawing/2014/main" id="{B4F18E1C-08A2-4FD8-86CC-0D99166D5E8C}"/>
+                <a16:creationId xmlns:a16="http://schemas.microsoft.com/office/drawing/2014/main" id="{91F3721B-D233-4150-AAC4-C6AE186119BA}"/>
               </a:ext>
             </a:extLst>
           </p:cNvPr>
@@ -2009,7 +2009,7 @@
           <p:cNvPr id="4" name="">
             <a:extLst xmlns:a="http://schemas.openxmlformats.org/drawingml/2006/main">
               <a:ext uri="{FF2B5EF4-FFF2-40B4-BE49-F238E27FC236}">
-                <a16:creationId xmlns:a16="http://schemas.microsoft.com/office/drawing/2014/main" id="{C342B85E-79EC-4A84-8730-52D213EFF798}"/>
+                <a16:creationId xmlns:a16="http://schemas.microsoft.com/office/drawing/2014/main" id="{7DB09145-3178-4B3B-ABA4-EF2ED8B41CA0}"/>
               </a:ext>
             </a:extLst>
           </p:cNvPr>
@@ -2066,7 +2066,7 @@
           <p:cNvPr id="5" name="">
             <a:extLst xmlns:a="http://schemas.openxmlformats.org/drawingml/2006/main">
               <a:ext uri="{FF2B5EF4-FFF2-40B4-BE49-F238E27FC236}">
-                <a16:creationId xmlns:a16="http://schemas.microsoft.com/office/drawing/2014/main" id="{AE87C193-A6ED-4FF8-8567-17251DFF2CD6}"/>
+                <a16:creationId xmlns:a16="http://schemas.microsoft.com/office/drawing/2014/main" id="{F0A058DC-E0C0-49BD-87FC-4A788C50C786}"/>
               </a:ext>
             </a:extLst>
           </p:cNvPr>
@@ -2146,7 +2146,7 @@
           <p:cNvPr id="6" name="">
             <a:extLst xmlns:a="http://schemas.openxmlformats.org/drawingml/2006/main">
               <a:ext uri="{FF2B5EF4-FFF2-40B4-BE49-F238E27FC236}">
-                <a16:creationId xmlns:a16="http://schemas.microsoft.com/office/drawing/2014/main" id="{2DFF672B-BA4F-4F78-B45F-7286796F2A7F}"/>
+                <a16:creationId xmlns:a16="http://schemas.microsoft.com/office/drawing/2014/main" id="{9960627E-B26A-431C-8B0B-3D1440898F83}"/>
               </a:ext>
             </a:extLst>
           </p:cNvPr>
@@ -2203,7 +2203,7 @@
           <p:cNvPr id="7" name="">
             <a:extLst xmlns:a="http://schemas.openxmlformats.org/drawingml/2006/main">
               <a:ext uri="{FF2B5EF4-FFF2-40B4-BE49-F238E27FC236}">
-                <a16:creationId xmlns:a16="http://schemas.microsoft.com/office/drawing/2014/main" id="{9A8CDF86-3B0C-4F17-BD1D-55968147CA23}"/>
+                <a16:creationId xmlns:a16="http://schemas.microsoft.com/office/drawing/2014/main" id="{FEA50D9D-B404-491D-8FD8-0ADD1857E994}"/>
               </a:ext>
             </a:extLst>
           </p:cNvPr>
@@ -2283,7 +2283,7 @@
           <p:cNvPr id="8" name="">
             <a:extLst xmlns:a="http://schemas.openxmlformats.org/drawingml/2006/main">
               <a:ext uri="{FF2B5EF4-FFF2-40B4-BE49-F238E27FC236}">
-                <a16:creationId xmlns:a16="http://schemas.microsoft.com/office/drawing/2014/main" id="{D7F3053A-B819-4EF5-8937-F18A8B8BFA28}"/>
+                <a16:creationId xmlns:a16="http://schemas.microsoft.com/office/drawing/2014/main" id="{B9359E33-43FA-4D54-9A93-79741A701CF8}"/>
               </a:ext>
             </a:extLst>
           </p:cNvPr>
@@ -2338,7 +2338,7 @@
     </p:spTree>
     <p:extLst>
       <p:ext uri="{BB962C8B-B14F-4D97-AF65-F5344CB8AC3E}">
-        <p14:creationId xmlns:p14="http://schemas.microsoft.com/office/powerpoint/2010/main" val="1512092815"/>
+        <p14:creationId xmlns:p14="http://schemas.microsoft.com/office/powerpoint/2010/main" val="332160701"/>
       </p:ext>
     </p:extLst>
   </p:cSld>
@@ -2369,7 +2369,7 @@
           <p:cNvPr id="34" name="">
             <a:extLst xmlns:a="http://schemas.openxmlformats.org/drawingml/2006/main">
               <a:ext uri="{FF2B5EF4-FFF2-40B4-BE49-F238E27FC236}">
-                <a16:creationId xmlns:a16="http://schemas.microsoft.com/office/drawing/2014/main" id="{DDBDC2F7-E522-4729-AFEE-D8E9C2069ED8}"/>
+                <a16:creationId xmlns:a16="http://schemas.microsoft.com/office/drawing/2014/main" id="{8416BB4D-DDBA-4FF5-AA9E-FE2B6151180A}"/>
               </a:ext>
             </a:extLst>
           </p:cNvPr>
@@ -2426,7 +2426,7 @@
           <p:cNvPr id="2" name="">
             <a:extLst xmlns:a="http://schemas.openxmlformats.org/drawingml/2006/main">
               <a:ext uri="{FF2B5EF4-FFF2-40B4-BE49-F238E27FC236}">
-                <a16:creationId xmlns:a16="http://schemas.microsoft.com/office/drawing/2014/main" id="{19AA449B-8107-404E-9219-8F88ECC4992E}"/>
+                <a16:creationId xmlns:a16="http://schemas.microsoft.com/office/drawing/2014/main" id="{0E61EB98-4ACF-45C4-A748-430BAAD969B0}"/>
               </a:ext>
             </a:extLst>
           </p:cNvPr>
@@ -2483,7 +2483,7 @@
           <p:cNvPr id="3" name="">
             <a:extLst xmlns:a="http://schemas.openxmlformats.org/drawingml/2006/main">
               <a:ext uri="{FF2B5EF4-FFF2-40B4-BE49-F238E27FC236}">
-                <a16:creationId xmlns:a16="http://schemas.microsoft.com/office/drawing/2014/main" id="{DB4E351C-D3D0-46AF-8439-83C850E7F1F9}"/>
+                <a16:creationId xmlns:a16="http://schemas.microsoft.com/office/drawing/2014/main" id="{96DAB1C3-CD73-4DCF-AE59-7E0FB0A47566}"/>
               </a:ext>
             </a:extLst>
           </p:cNvPr>
@@ -2513,7 +2513,7 @@
           <p:cNvPr id="4" name="">
             <a:extLst xmlns:a="http://schemas.openxmlformats.org/drawingml/2006/main">
               <a:ext uri="{FF2B5EF4-FFF2-40B4-BE49-F238E27FC236}">
-                <a16:creationId xmlns:a16="http://schemas.microsoft.com/office/drawing/2014/main" id="{DBB67E8F-4BDB-4894-821E-EEF3FA53CB0F}"/>
+                <a16:creationId xmlns:a16="http://schemas.microsoft.com/office/drawing/2014/main" id="{8CD52CB8-9484-4E60-8F72-EAF2A9F17796}"/>
               </a:ext>
             </a:extLst>
           </p:cNvPr>
@@ -2570,7 +2570,7 @@
           <p:cNvPr id="5" name="">
             <a:extLst xmlns:a="http://schemas.openxmlformats.org/drawingml/2006/main">
               <a:ext uri="{FF2B5EF4-FFF2-40B4-BE49-F238E27FC236}">
-                <a16:creationId xmlns:a16="http://schemas.microsoft.com/office/drawing/2014/main" id="{A9ABB8BE-0B22-4530-8D2E-18EC89688A1B}"/>
+                <a16:creationId xmlns:a16="http://schemas.microsoft.com/office/drawing/2014/main" id="{974AE3A9-E740-4A71-9186-E65899F35989}"/>
               </a:ext>
             </a:extLst>
           </p:cNvPr>
@@ -2627,7 +2627,7 @@
           <p:cNvPr id="6" name="">
             <a:extLst xmlns:a="http://schemas.openxmlformats.org/drawingml/2006/main">
               <a:ext uri="{FF2B5EF4-FFF2-40B4-BE49-F238E27FC236}">
-                <a16:creationId xmlns:a16="http://schemas.microsoft.com/office/drawing/2014/main" id="{39F36DB1-88C8-4E51-A23B-9A7D98029863}"/>
+                <a16:creationId xmlns:a16="http://schemas.microsoft.com/office/drawing/2014/main" id="{AC5FCE54-0B5B-42D9-8EA7-58FC00EC48F8}"/>
               </a:ext>
             </a:extLst>
           </p:cNvPr>
@@ -2684,7 +2684,7 @@
           <p:cNvPr id="7" name="">
             <a:extLst xmlns:a="http://schemas.openxmlformats.org/drawingml/2006/main">
               <a:ext uri="{FF2B5EF4-FFF2-40B4-BE49-F238E27FC236}">
-                <a16:creationId xmlns:a16="http://schemas.microsoft.com/office/drawing/2014/main" id="{7A435A34-60D8-47D0-A88C-109689AA0E3D}"/>
+                <a16:creationId xmlns:a16="http://schemas.microsoft.com/office/drawing/2014/main" id="{F20CA9D3-B33C-490E-AA3D-49D8805074B8}"/>
               </a:ext>
             </a:extLst>
           </p:cNvPr>
@@ -2714,7 +2714,7 @@
           <p:cNvPr id="8" name="">
             <a:extLst xmlns:a="http://schemas.openxmlformats.org/drawingml/2006/main">
               <a:ext uri="{FF2B5EF4-FFF2-40B4-BE49-F238E27FC236}">
-                <a16:creationId xmlns:a16="http://schemas.microsoft.com/office/drawing/2014/main" id="{6F087C54-58DE-4D59-A44E-752403D77C93}"/>
+                <a16:creationId xmlns:a16="http://schemas.microsoft.com/office/drawing/2014/main" id="{8EB273FD-7584-41CA-AC5C-0046CF9707CA}"/>
               </a:ext>
             </a:extLst>
           </p:cNvPr>
@@ -2771,7 +2771,7 @@
           <p:cNvPr id="9" name="">
             <a:extLst xmlns:a="http://schemas.openxmlformats.org/drawingml/2006/main">
               <a:ext uri="{FF2B5EF4-FFF2-40B4-BE49-F238E27FC236}">
-                <a16:creationId xmlns:a16="http://schemas.microsoft.com/office/drawing/2014/main" id="{6D38069B-F884-4F41-BB4C-1E4AF0F24811}"/>
+                <a16:creationId xmlns:a16="http://schemas.microsoft.com/office/drawing/2014/main" id="{B6CCC83D-8307-4A52-89BA-3E2D9B89C600}"/>
               </a:ext>
             </a:extLst>
           </p:cNvPr>
@@ -2828,7 +2828,7 @@
           <p:cNvPr id="10" name="">
             <a:extLst xmlns:a="http://schemas.openxmlformats.org/drawingml/2006/main">
               <a:ext uri="{FF2B5EF4-FFF2-40B4-BE49-F238E27FC236}">
-                <a16:creationId xmlns:a16="http://schemas.microsoft.com/office/drawing/2014/main" id="{C6E3BE8D-FB84-4989-B030-237AC1F9BB5F}"/>
+                <a16:creationId xmlns:a16="http://schemas.microsoft.com/office/drawing/2014/main" id="{BDDB66DF-0ACD-4656-84F6-9DD10B8E1FD6}"/>
               </a:ext>
             </a:extLst>
           </p:cNvPr>
@@ -2885,7 +2885,7 @@
           <p:cNvPr id="11" name="">
             <a:extLst xmlns:a="http://schemas.openxmlformats.org/drawingml/2006/main">
               <a:ext uri="{FF2B5EF4-FFF2-40B4-BE49-F238E27FC236}">
-                <a16:creationId xmlns:a16="http://schemas.microsoft.com/office/drawing/2014/main" id="{0368CA7D-BA25-46DB-9923-497497DB65AA}"/>
+                <a16:creationId xmlns:a16="http://schemas.microsoft.com/office/drawing/2014/main" id="{40F59A7A-7628-4C96-B0FD-5F2EAC9986EB}"/>
               </a:ext>
             </a:extLst>
           </p:cNvPr>
@@ -2915,7 +2915,7 @@
           <p:cNvPr id="12" name="">
             <a:extLst xmlns:a="http://schemas.openxmlformats.org/drawingml/2006/main">
               <a:ext uri="{FF2B5EF4-FFF2-40B4-BE49-F238E27FC236}">
-                <a16:creationId xmlns:a16="http://schemas.microsoft.com/office/drawing/2014/main" id="{EDFB295E-F71F-4B85-BFDD-D7A275B12FD2}"/>
+                <a16:creationId xmlns:a16="http://schemas.microsoft.com/office/drawing/2014/main" id="{38CB6238-4E34-45E7-9B5A-B800DDD1BFA2}"/>
               </a:ext>
             </a:extLst>
           </p:cNvPr>
@@ -2972,7 +2972,7 @@
           <p:cNvPr id="13" name="">
             <a:extLst xmlns:a="http://schemas.openxmlformats.org/drawingml/2006/main">
               <a:ext uri="{FF2B5EF4-FFF2-40B4-BE49-F238E27FC236}">
-                <a16:creationId xmlns:a16="http://schemas.microsoft.com/office/drawing/2014/main" id="{C3E15BE9-5D7F-4A2C-97FA-D893EF717079}"/>
+                <a16:creationId xmlns:a16="http://schemas.microsoft.com/office/drawing/2014/main" id="{80020CCC-6885-465B-A816-205DA208C5B2}"/>
               </a:ext>
             </a:extLst>
           </p:cNvPr>
@@ -3029,7 +3029,7 @@
           <p:cNvPr id="14" name="">
             <a:extLst xmlns:a="http://schemas.openxmlformats.org/drawingml/2006/main">
               <a:ext uri="{FF2B5EF4-FFF2-40B4-BE49-F238E27FC236}">
-                <a16:creationId xmlns:a16="http://schemas.microsoft.com/office/drawing/2014/main" id="{074E6E0D-1E0A-4C10-ADE9-2128FDFCDE7E}"/>
+                <a16:creationId xmlns:a16="http://schemas.microsoft.com/office/drawing/2014/main" id="{063BA8EF-C16D-4EEA-9892-FE1041D23A22}"/>
               </a:ext>
             </a:extLst>
           </p:cNvPr>
@@ -3086,7 +3086,7 @@
           <p:cNvPr id="15" name="">
             <a:extLst xmlns:a="http://schemas.openxmlformats.org/drawingml/2006/main">
               <a:ext uri="{FF2B5EF4-FFF2-40B4-BE49-F238E27FC236}">
-                <a16:creationId xmlns:a16="http://schemas.microsoft.com/office/drawing/2014/main" id="{9709AD92-E3DD-4E3B-9E0F-7A60896F19BD}"/>
+                <a16:creationId xmlns:a16="http://schemas.microsoft.com/office/drawing/2014/main" id="{335DA1D5-066D-46D2-8EBC-6E42C0F79B28}"/>
               </a:ext>
             </a:extLst>
           </p:cNvPr>
@@ -3116,7 +3116,7 @@
           <p:cNvPr id="16" name="">
             <a:extLst xmlns:a="http://schemas.openxmlformats.org/drawingml/2006/main">
               <a:ext uri="{FF2B5EF4-FFF2-40B4-BE49-F238E27FC236}">
-                <a16:creationId xmlns:a16="http://schemas.microsoft.com/office/drawing/2014/main" id="{0724046C-F452-4AEE-80DB-993D00804602}"/>
+                <a16:creationId xmlns:a16="http://schemas.microsoft.com/office/drawing/2014/main" id="{CB5A42FA-4EA8-4343-BDFD-75D1919A124A}"/>
               </a:ext>
             </a:extLst>
           </p:cNvPr>
@@ -3173,7 +3173,7 @@
           <p:cNvPr id="17" name="">
             <a:extLst xmlns:a="http://schemas.openxmlformats.org/drawingml/2006/main">
               <a:ext uri="{FF2B5EF4-FFF2-40B4-BE49-F238E27FC236}">
-                <a16:creationId xmlns:a16="http://schemas.microsoft.com/office/drawing/2014/main" id="{60C1757A-A7DC-42B0-B670-CD4850EEBB58}"/>
+                <a16:creationId xmlns:a16="http://schemas.microsoft.com/office/drawing/2014/main" id="{5B416BFD-9DA5-4A79-946B-E3851D18240D}"/>
               </a:ext>
             </a:extLst>
           </p:cNvPr>
@@ -3230,7 +3230,7 @@
           <p:cNvPr id="18" name="">
             <a:extLst xmlns:a="http://schemas.openxmlformats.org/drawingml/2006/main">
               <a:ext uri="{FF2B5EF4-FFF2-40B4-BE49-F238E27FC236}">
-                <a16:creationId xmlns:a16="http://schemas.microsoft.com/office/drawing/2014/main" id="{4677434E-7ACE-4CB2-8A43-81B3F019CE22}"/>
+                <a16:creationId xmlns:a16="http://schemas.microsoft.com/office/drawing/2014/main" id="{D1430354-2F3D-4F77-91BA-F1F8562610B5}"/>
               </a:ext>
             </a:extLst>
           </p:cNvPr>
@@ -3287,7 +3287,7 @@
           <p:cNvPr id="19" name="">
             <a:extLst xmlns:a="http://schemas.openxmlformats.org/drawingml/2006/main">
               <a:ext uri="{FF2B5EF4-FFF2-40B4-BE49-F238E27FC236}">
-                <a16:creationId xmlns:a16="http://schemas.microsoft.com/office/drawing/2014/main" id="{6275D426-8AA3-40AC-966D-83A1A4AC58A3}"/>
+                <a16:creationId xmlns:a16="http://schemas.microsoft.com/office/drawing/2014/main" id="{8383FD61-6934-4A4C-92B6-100ED1FB5845}"/>
               </a:ext>
             </a:extLst>
           </p:cNvPr>
@@ -3317,7 +3317,7 @@
           <p:cNvPr id="20" name="">
             <a:extLst xmlns:a="http://schemas.openxmlformats.org/drawingml/2006/main">
               <a:ext uri="{FF2B5EF4-FFF2-40B4-BE49-F238E27FC236}">
-                <a16:creationId xmlns:a16="http://schemas.microsoft.com/office/drawing/2014/main" id="{0C0CCD02-73BA-4679-8C35-10C2EBD2FD73}"/>
+                <a16:creationId xmlns:a16="http://schemas.microsoft.com/office/drawing/2014/main" id="{C3EB8807-127E-446B-9C50-56A8836B6176}"/>
               </a:ext>
             </a:extLst>
           </p:cNvPr>
@@ -3374,7 +3374,7 @@
           <p:cNvPr id="21" name="">
             <a:extLst xmlns:a="http://schemas.openxmlformats.org/drawingml/2006/main">
               <a:ext uri="{FF2B5EF4-FFF2-40B4-BE49-F238E27FC236}">
-                <a16:creationId xmlns:a16="http://schemas.microsoft.com/office/drawing/2014/main" id="{8FB8421F-750D-4878-B5A9-49E31E774007}"/>
+                <a16:creationId xmlns:a16="http://schemas.microsoft.com/office/drawing/2014/main" id="{AE9C7369-C6AE-4CB2-B3DB-CE4BF383A760}"/>
               </a:ext>
             </a:extLst>
           </p:cNvPr>
@@ -3431,7 +3431,7 @@
           <p:cNvPr id="22" name="">
             <a:extLst xmlns:a="http://schemas.openxmlformats.org/drawingml/2006/main">
               <a:ext uri="{FF2B5EF4-FFF2-40B4-BE49-F238E27FC236}">
-                <a16:creationId xmlns:a16="http://schemas.microsoft.com/office/drawing/2014/main" id="{7F8194AD-F250-44F9-863E-56340C0695EE}"/>
+                <a16:creationId xmlns:a16="http://schemas.microsoft.com/office/drawing/2014/main" id="{6BEA5A44-76F5-4D85-836A-FD33E2F8425A}"/>
               </a:ext>
             </a:extLst>
           </p:cNvPr>
@@ -3488,7 +3488,7 @@
           <p:cNvPr id="23" name="">
             <a:extLst xmlns:a="http://schemas.openxmlformats.org/drawingml/2006/main">
               <a:ext uri="{FF2B5EF4-FFF2-40B4-BE49-F238E27FC236}">
-                <a16:creationId xmlns:a16="http://schemas.microsoft.com/office/drawing/2014/main" id="{4343E0ED-F9B1-4DE0-A157-8E86B7378622}"/>
+                <a16:creationId xmlns:a16="http://schemas.microsoft.com/office/drawing/2014/main" id="{A41757A1-1A84-480E-BCD9-60288BAE7CE7}"/>
               </a:ext>
             </a:extLst>
           </p:cNvPr>
@@ -3518,7 +3518,7 @@
           <p:cNvPr id="24" name="">
             <a:extLst xmlns:a="http://schemas.openxmlformats.org/drawingml/2006/main">
               <a:ext uri="{FF2B5EF4-FFF2-40B4-BE49-F238E27FC236}">
-                <a16:creationId xmlns:a16="http://schemas.microsoft.com/office/drawing/2014/main" id="{ED05A9A0-69D3-42CE-AF5F-5112E1D86271}"/>
+                <a16:creationId xmlns:a16="http://schemas.microsoft.com/office/drawing/2014/main" id="{3B6B3791-AC40-451B-8CED-E516159C0132}"/>
               </a:ext>
             </a:extLst>
           </p:cNvPr>
@@ -3575,7 +3575,7 @@
           <p:cNvPr id="25" name="">
             <a:extLst xmlns:a="http://schemas.openxmlformats.org/drawingml/2006/main">
               <a:ext uri="{FF2B5EF4-FFF2-40B4-BE49-F238E27FC236}">
-                <a16:creationId xmlns:a16="http://schemas.microsoft.com/office/drawing/2014/main" id="{9F0B98B8-2C06-4170-9E53-4A8DDFAB51DA}"/>
+                <a16:creationId xmlns:a16="http://schemas.microsoft.com/office/drawing/2014/main" id="{BE2BD3E2-F239-4705-BEA6-F0525AC2086C}"/>
               </a:ext>
             </a:extLst>
           </p:cNvPr>
@@ -3632,7 +3632,7 @@
           <p:cNvPr id="26" name="">
             <a:extLst xmlns:a="http://schemas.openxmlformats.org/drawingml/2006/main">
               <a:ext uri="{FF2B5EF4-FFF2-40B4-BE49-F238E27FC236}">
-                <a16:creationId xmlns:a16="http://schemas.microsoft.com/office/drawing/2014/main" id="{CCF47EBA-908E-4A22-8537-4675CE4C675D}"/>
+                <a16:creationId xmlns:a16="http://schemas.microsoft.com/office/drawing/2014/main" id="{23BD70D8-DA4B-48DC-8313-0B342D0E547E}"/>
               </a:ext>
             </a:extLst>
           </p:cNvPr>
@@ -3814,7 +3814,7 @@
           <p:cNvPr id="32" name="">
             <a:extLst xmlns:a="http://schemas.openxmlformats.org/drawingml/2006/main">
               <a:ext uri="{FF2B5EF4-FFF2-40B4-BE49-F238E27FC236}">
-                <a16:creationId xmlns:a16="http://schemas.microsoft.com/office/drawing/2014/main" id="{6D09F41D-65F3-4528-9F56-EBCF6E3A7CEA}"/>
+                <a16:creationId xmlns:a16="http://schemas.microsoft.com/office/drawing/2014/main" id="{7E32F0EF-5963-4B67-81C9-5C21867788A1}"/>
               </a:ext>
             </a:extLst>
           </p:cNvPr>
@@ -3871,7 +3871,7 @@
           <p:cNvPr id="33" name="">
             <a:extLst xmlns:a="http://schemas.openxmlformats.org/drawingml/2006/main">
               <a:ext uri="{FF2B5EF4-FFF2-40B4-BE49-F238E27FC236}">
-                <a16:creationId xmlns:a16="http://schemas.microsoft.com/office/drawing/2014/main" id="{07DAB726-88FE-499E-9A65-30D94A28657D}"/>
+                <a16:creationId xmlns:a16="http://schemas.microsoft.com/office/drawing/2014/main" id="{EDDF7DCD-C12C-4D28-A980-84BB644C064F}"/>
               </a:ext>
             </a:extLst>
           </p:cNvPr>
@@ -3926,7 +3926,7 @@
     </p:spTree>
     <p:extLst>
       <p:ext uri="{BB962C8B-B14F-4D97-AF65-F5344CB8AC3E}">
-        <p14:creationId xmlns:p14="http://schemas.microsoft.com/office/powerpoint/2010/main" val="1154492034"/>
+        <p14:creationId xmlns:p14="http://schemas.microsoft.com/office/powerpoint/2010/main" val="228444536"/>
       </p:ext>
     </p:extLst>
   </p:cSld>
@@ -3957,7 +3957,7 @@
           <p:cNvPr id="12" name="">
             <a:extLst xmlns:a="http://schemas.openxmlformats.org/drawingml/2006/main">
               <a:ext uri="{FF2B5EF4-FFF2-40B4-BE49-F238E27FC236}">
-                <a16:creationId xmlns:a16="http://schemas.microsoft.com/office/drawing/2014/main" id="{905462E2-93B0-4D5D-AF68-C39C2696942B}"/>
+                <a16:creationId xmlns:a16="http://schemas.microsoft.com/office/drawing/2014/main" id="{C6E9364C-95C9-470A-B73A-6C4E053591DE}"/>
               </a:ext>
             </a:extLst>
           </p:cNvPr>
@@ -4014,7 +4014,7 @@
           <p:cNvPr id="2" name="">
             <a:extLst xmlns:a="http://schemas.openxmlformats.org/drawingml/2006/main">
               <a:ext uri="{FF2B5EF4-FFF2-40B4-BE49-F238E27FC236}">
-                <a16:creationId xmlns:a16="http://schemas.microsoft.com/office/drawing/2014/main" id="{C62B507C-17CD-4F98-9429-25F0E6CA85AE}"/>
+                <a16:creationId xmlns:a16="http://schemas.microsoft.com/office/drawing/2014/main" id="{2AEACBCE-01B4-47C4-8691-820157215237}"/>
               </a:ext>
             </a:extLst>
           </p:cNvPr>
@@ -4071,7 +4071,7 @@
           <p:cNvPr id="3" name="">
             <a:extLst xmlns:a="http://schemas.openxmlformats.org/drawingml/2006/main">
               <a:ext uri="{FF2B5EF4-FFF2-40B4-BE49-F238E27FC236}">
-                <a16:creationId xmlns:a16="http://schemas.microsoft.com/office/drawing/2014/main" id="{464CD0E8-FB4A-4F2D-887D-954A3D84EE67}"/>
+                <a16:creationId xmlns:a16="http://schemas.microsoft.com/office/drawing/2014/main" id="{E467751A-1DAE-4334-B3FC-2CCC3A8860B9}"/>
               </a:ext>
             </a:extLst>
           </p:cNvPr>
@@ -4128,7 +4128,7 @@
           <p:cNvPr id="4" name="">
             <a:extLst xmlns:a="http://schemas.openxmlformats.org/drawingml/2006/main">
               <a:ext uri="{FF2B5EF4-FFF2-40B4-BE49-F238E27FC236}">
-                <a16:creationId xmlns:a16="http://schemas.microsoft.com/office/drawing/2014/main" id="{D4717D37-2BED-434F-ACE2-0D725D2981F5}"/>
+                <a16:creationId xmlns:a16="http://schemas.microsoft.com/office/drawing/2014/main" id="{5149B7D5-95BD-4707-81F5-83DD2D58CE6A}"/>
               </a:ext>
             </a:extLst>
           </p:cNvPr>
@@ -4185,7 +4185,7 @@
           <p:cNvPr id="5" name="">
             <a:extLst xmlns:a="http://schemas.openxmlformats.org/drawingml/2006/main">
               <a:ext uri="{FF2B5EF4-FFF2-40B4-BE49-F238E27FC236}">
-                <a16:creationId xmlns:a16="http://schemas.microsoft.com/office/drawing/2014/main" id="{47B19BA8-34ED-447D-9206-B48AFA328F0D}"/>
+                <a16:creationId xmlns:a16="http://schemas.microsoft.com/office/drawing/2014/main" id="{40E9AB59-E560-4B79-914E-B78AE4B1103C}"/>
               </a:ext>
             </a:extLst>
           </p:cNvPr>
@@ -4242,7 +4242,7 @@
           <p:cNvPr id="6" name="">
             <a:extLst xmlns:a="http://schemas.openxmlformats.org/drawingml/2006/main">
               <a:ext uri="{FF2B5EF4-FFF2-40B4-BE49-F238E27FC236}">
-                <a16:creationId xmlns:a16="http://schemas.microsoft.com/office/drawing/2014/main" id="{977C0496-7640-4B78-8CE0-F5AB49C6144C}"/>
+                <a16:creationId xmlns:a16="http://schemas.microsoft.com/office/drawing/2014/main" id="{1EE0553E-E63C-4878-A87B-9A65047D912A}"/>
               </a:ext>
             </a:extLst>
           </p:cNvPr>
@@ -4299,7 +4299,7 @@
           <p:cNvPr id="7" name="">
             <a:extLst xmlns:a="http://schemas.openxmlformats.org/drawingml/2006/main">
               <a:ext uri="{FF2B5EF4-FFF2-40B4-BE49-F238E27FC236}">
-                <a16:creationId xmlns:a16="http://schemas.microsoft.com/office/drawing/2014/main" id="{520EA39F-E4E0-459B-9AF8-A70D6C9E1201}"/>
+                <a16:creationId xmlns:a16="http://schemas.microsoft.com/office/drawing/2014/main" id="{E4333777-1051-4525-BA48-39975916285F}"/>
               </a:ext>
             </a:extLst>
           </p:cNvPr>
@@ -4356,7 +4356,7 @@
           <p:cNvPr id="8" name="">
             <a:extLst xmlns:a="http://schemas.openxmlformats.org/drawingml/2006/main">
               <a:ext uri="{FF2B5EF4-FFF2-40B4-BE49-F238E27FC236}">
-                <a16:creationId xmlns:a16="http://schemas.microsoft.com/office/drawing/2014/main" id="{DEF199F6-8D84-4F6E-BD55-1CE53E71A33C}"/>
+                <a16:creationId xmlns:a16="http://schemas.microsoft.com/office/drawing/2014/main" id="{BE82AC7D-D6D9-499A-B6C5-E744881F93DD}"/>
               </a:ext>
             </a:extLst>
           </p:cNvPr>
@@ -4413,7 +4413,7 @@
           <p:cNvPr id="9" name="">
             <a:extLst xmlns:a="http://schemas.openxmlformats.org/drawingml/2006/main">
               <a:ext uri="{FF2B5EF4-FFF2-40B4-BE49-F238E27FC236}">
-                <a16:creationId xmlns:a16="http://schemas.microsoft.com/office/drawing/2014/main" id="{7E96EE58-57B2-4089-A717-C487E7D2647B}"/>
+                <a16:creationId xmlns:a16="http://schemas.microsoft.com/office/drawing/2014/main" id="{5243F794-0B5D-4AA7-9D00-62FE36422037}"/>
               </a:ext>
             </a:extLst>
           </p:cNvPr>
@@ -4493,7 +4493,7 @@
           <p:cNvPr id="10" name="">
             <a:extLst xmlns:a="http://schemas.openxmlformats.org/drawingml/2006/main">
               <a:ext uri="{FF2B5EF4-FFF2-40B4-BE49-F238E27FC236}">
-                <a16:creationId xmlns:a16="http://schemas.microsoft.com/office/drawing/2014/main" id="{8AE85F4E-5E55-444F-99B8-908A5B86A3D8}"/>
+                <a16:creationId xmlns:a16="http://schemas.microsoft.com/office/drawing/2014/main" id="{52E47CE3-FBE5-4BF2-B347-59B2FF6CEA1D}"/>
               </a:ext>
             </a:extLst>
           </p:cNvPr>
@@ -4573,7 +4573,7 @@
           <p:cNvPr id="11" name="">
             <a:extLst xmlns:a="http://schemas.openxmlformats.org/drawingml/2006/main">
               <a:ext uri="{FF2B5EF4-FFF2-40B4-BE49-F238E27FC236}">
-                <a16:creationId xmlns:a16="http://schemas.microsoft.com/office/drawing/2014/main" id="{C16E1E74-9292-4FF2-97D7-3B331A9ADEDA}"/>
+                <a16:creationId xmlns:a16="http://schemas.microsoft.com/office/drawing/2014/main" id="{559AB991-286C-4D13-987C-64A4EABB195B}"/>
               </a:ext>
             </a:extLst>
           </p:cNvPr>
@@ -4628,7 +4628,7 @@
     </p:spTree>
     <p:extLst>
       <p:ext uri="{BB962C8B-B14F-4D97-AF65-F5344CB8AC3E}">
-        <p14:creationId xmlns:p14="http://schemas.microsoft.com/office/powerpoint/2010/main" val="1824512739"/>
+        <p14:creationId xmlns:p14="http://schemas.microsoft.com/office/powerpoint/2010/main" val="1502910094"/>
       </p:ext>
     </p:extLst>
   </p:cSld>
@@ -4659,7 +4659,7 @@
           <p:cNvPr id="28" name="">
             <a:extLst xmlns:a="http://schemas.openxmlformats.org/drawingml/2006/main">
               <a:ext uri="{FF2B5EF4-FFF2-40B4-BE49-F238E27FC236}">
-                <a16:creationId xmlns:a16="http://schemas.microsoft.com/office/drawing/2014/main" id="{196C5987-001E-44B1-AD49-CB29E2F6A225}"/>
+                <a16:creationId xmlns:a16="http://schemas.microsoft.com/office/drawing/2014/main" id="{4F9FB53F-8B0C-41D5-8E6F-1CC5C237358A}"/>
               </a:ext>
             </a:extLst>
           </p:cNvPr>
@@ -4716,7 +4716,7 @@
           <p:cNvPr id="2" name="">
             <a:extLst xmlns:a="http://schemas.openxmlformats.org/drawingml/2006/main">
               <a:ext uri="{FF2B5EF4-FFF2-40B4-BE49-F238E27FC236}">
-                <a16:creationId xmlns:a16="http://schemas.microsoft.com/office/drawing/2014/main" id="{C85CD450-8FBC-4027-B572-B5A29DD6A09D}"/>
+                <a16:creationId xmlns:a16="http://schemas.microsoft.com/office/drawing/2014/main" id="{A75D8F0A-60CA-4FBD-A80A-514E886D48E4}"/>
               </a:ext>
             </a:extLst>
           </p:cNvPr>
@@ -4773,7 +4773,7 @@
           <p:cNvPr id="3" name="">
             <a:extLst xmlns:a="http://schemas.openxmlformats.org/drawingml/2006/main">
               <a:ext uri="{FF2B5EF4-FFF2-40B4-BE49-F238E27FC236}">
-                <a16:creationId xmlns:a16="http://schemas.microsoft.com/office/drawing/2014/main" id="{8C389098-8CF1-4F72-BF6E-31E00F0B0AB6}"/>
+                <a16:creationId xmlns:a16="http://schemas.microsoft.com/office/drawing/2014/main" id="{D679C4EF-A7E2-483D-B6AE-869059FCAB22}"/>
               </a:ext>
             </a:extLst>
           </p:cNvPr>
@@ -4803,7 +4803,7 @@
           <p:cNvPr id="4" name="">
             <a:extLst xmlns:a="http://schemas.openxmlformats.org/drawingml/2006/main">
               <a:ext uri="{FF2B5EF4-FFF2-40B4-BE49-F238E27FC236}">
-                <a16:creationId xmlns:a16="http://schemas.microsoft.com/office/drawing/2014/main" id="{20584E5E-F044-4125-814C-C5AC57338C5F}"/>
+                <a16:creationId xmlns:a16="http://schemas.microsoft.com/office/drawing/2014/main" id="{880E954F-90A8-45A4-A599-5B4FDF40D52B}"/>
               </a:ext>
             </a:extLst>
           </p:cNvPr>
@@ -4860,7 +4860,7 @@
           <p:cNvPr id="5" name="">
             <a:extLst xmlns:a="http://schemas.openxmlformats.org/drawingml/2006/main">
               <a:ext uri="{FF2B5EF4-FFF2-40B4-BE49-F238E27FC236}">
-                <a16:creationId xmlns:a16="http://schemas.microsoft.com/office/drawing/2014/main" id="{0345F0F9-FF2B-4CA8-B2AD-636D2DC12815}"/>
+                <a16:creationId xmlns:a16="http://schemas.microsoft.com/office/drawing/2014/main" id="{F6E3F7F8-C128-4B40-A27C-9DC83D74BE82}"/>
               </a:ext>
             </a:extLst>
           </p:cNvPr>
@@ -4917,7 +4917,7 @@
           <p:cNvPr id="6" name="">
             <a:extLst xmlns:a="http://schemas.openxmlformats.org/drawingml/2006/main">
               <a:ext uri="{FF2B5EF4-FFF2-40B4-BE49-F238E27FC236}">
-                <a16:creationId xmlns:a16="http://schemas.microsoft.com/office/drawing/2014/main" id="{321D6E92-8073-451D-9610-0C9E5397D792}"/>
+                <a16:creationId xmlns:a16="http://schemas.microsoft.com/office/drawing/2014/main" id="{0FD2E5DC-5E3D-4BEB-BA01-BC39A6A1DB8C}"/>
               </a:ext>
             </a:extLst>
           </p:cNvPr>
@@ -4947,7 +4947,7 @@
           <p:cNvPr id="7" name="">
             <a:extLst xmlns:a="http://schemas.openxmlformats.org/drawingml/2006/main">
               <a:ext uri="{FF2B5EF4-FFF2-40B4-BE49-F238E27FC236}">
-                <a16:creationId xmlns:a16="http://schemas.microsoft.com/office/drawing/2014/main" id="{95EAFCCD-E238-4912-ABDE-9F65ACDE8E68}"/>
+                <a16:creationId xmlns:a16="http://schemas.microsoft.com/office/drawing/2014/main" id="{C1B5B7B9-FEF6-4863-98CC-AD1A7586AF33}"/>
               </a:ext>
             </a:extLst>
           </p:cNvPr>
@@ -5004,7 +5004,7 @@
           <p:cNvPr id="8" name="">
             <a:extLst xmlns:a="http://schemas.openxmlformats.org/drawingml/2006/main">
               <a:ext uri="{FF2B5EF4-FFF2-40B4-BE49-F238E27FC236}">
-                <a16:creationId xmlns:a16="http://schemas.microsoft.com/office/drawing/2014/main" id="{7DBD7170-A0C5-4A7B-BC99-4BA45F11B016}"/>
+                <a16:creationId xmlns:a16="http://schemas.microsoft.com/office/drawing/2014/main" id="{2BA8CC0C-056E-4706-A649-6C9BFF0421A4}"/>
               </a:ext>
             </a:extLst>
           </p:cNvPr>
@@ -5061,7 +5061,7 @@
           <p:cNvPr id="9" name="">
             <a:extLst xmlns:a="http://schemas.openxmlformats.org/drawingml/2006/main">
               <a:ext uri="{FF2B5EF4-FFF2-40B4-BE49-F238E27FC236}">
-                <a16:creationId xmlns:a16="http://schemas.microsoft.com/office/drawing/2014/main" id="{744B946F-6D35-45C7-939D-27A86795272E}"/>
+                <a16:creationId xmlns:a16="http://schemas.microsoft.com/office/drawing/2014/main" id="{D12BA04C-7FB9-4640-8246-7D722F7A000B}"/>
               </a:ext>
             </a:extLst>
           </p:cNvPr>
@@ -5091,7 +5091,7 @@
           <p:cNvPr id="10" name="">
             <a:extLst xmlns:a="http://schemas.openxmlformats.org/drawingml/2006/main">
               <a:ext uri="{FF2B5EF4-FFF2-40B4-BE49-F238E27FC236}">
-                <a16:creationId xmlns:a16="http://schemas.microsoft.com/office/drawing/2014/main" id="{9261F0C5-DCDB-4D02-A0B4-A9A3321990C8}"/>
+                <a16:creationId xmlns:a16="http://schemas.microsoft.com/office/drawing/2014/main" id="{C293F6BF-D6CF-44BF-84AD-DE0692BD78D8}"/>
               </a:ext>
             </a:extLst>
           </p:cNvPr>
@@ -5148,7 +5148,7 @@
           <p:cNvPr id="11" name="">
             <a:extLst xmlns:a="http://schemas.openxmlformats.org/drawingml/2006/main">
               <a:ext uri="{FF2B5EF4-FFF2-40B4-BE49-F238E27FC236}">
-                <a16:creationId xmlns:a16="http://schemas.microsoft.com/office/drawing/2014/main" id="{BBCA3B01-F91C-41BF-93B3-7AD39A4CB69F}"/>
+                <a16:creationId xmlns:a16="http://schemas.microsoft.com/office/drawing/2014/main" id="{E6B6B502-81F1-4642-8BE2-78509159FD3C}"/>
               </a:ext>
             </a:extLst>
           </p:cNvPr>
@@ -5205,7 +5205,7 @@
           <p:cNvPr id="12" name="">
             <a:extLst xmlns:a="http://schemas.openxmlformats.org/drawingml/2006/main">
               <a:ext uri="{FF2B5EF4-FFF2-40B4-BE49-F238E27FC236}">
-                <a16:creationId xmlns:a16="http://schemas.microsoft.com/office/drawing/2014/main" id="{54B8CE72-14C9-4B6E-8E66-046BB1AED857}"/>
+                <a16:creationId xmlns:a16="http://schemas.microsoft.com/office/drawing/2014/main" id="{8CE5DBB3-720E-4090-ADE1-471B595D384C}"/>
               </a:ext>
             </a:extLst>
           </p:cNvPr>
@@ -5235,7 +5235,7 @@
           <p:cNvPr id="13" name="">
             <a:extLst xmlns:a="http://schemas.openxmlformats.org/drawingml/2006/main">
               <a:ext uri="{FF2B5EF4-FFF2-40B4-BE49-F238E27FC236}">
-                <a16:creationId xmlns:a16="http://schemas.microsoft.com/office/drawing/2014/main" id="{F9EC44D0-5CBE-4883-8B63-2ED6A84C9E1A}"/>
+                <a16:creationId xmlns:a16="http://schemas.microsoft.com/office/drawing/2014/main" id="{97574270-3363-4136-A15C-CE98E50599BA}"/>
               </a:ext>
             </a:extLst>
           </p:cNvPr>
@@ -5292,7 +5292,7 @@
           <p:cNvPr id="14" name="">
             <a:extLst xmlns:a="http://schemas.openxmlformats.org/drawingml/2006/main">
               <a:ext uri="{FF2B5EF4-FFF2-40B4-BE49-F238E27FC236}">
-                <a16:creationId xmlns:a16="http://schemas.microsoft.com/office/drawing/2014/main" id="{F13B27C9-B20D-4811-B58D-D3A504C26343}"/>
+                <a16:creationId xmlns:a16="http://schemas.microsoft.com/office/drawing/2014/main" id="{0E1DABE0-CD8B-4723-9987-5A07EA0F83C3}"/>
               </a:ext>
             </a:extLst>
           </p:cNvPr>
@@ -5349,7 +5349,7 @@
           <p:cNvPr id="15" name="">
             <a:extLst xmlns:a="http://schemas.openxmlformats.org/drawingml/2006/main">
               <a:ext uri="{FF2B5EF4-FFF2-40B4-BE49-F238E27FC236}">
-                <a16:creationId xmlns:a16="http://schemas.microsoft.com/office/drawing/2014/main" id="{42715E32-6D5F-4C15-AF1B-9484205C3643}"/>
+                <a16:creationId xmlns:a16="http://schemas.microsoft.com/office/drawing/2014/main" id="{F5CD4A7D-C077-47C6-85A7-3F44DDCE1096}"/>
               </a:ext>
             </a:extLst>
           </p:cNvPr>
@@ -5379,7 +5379,7 @@
           <p:cNvPr id="16" name="">
             <a:extLst xmlns:a="http://schemas.openxmlformats.org/drawingml/2006/main">
               <a:ext uri="{FF2B5EF4-FFF2-40B4-BE49-F238E27FC236}">
-                <a16:creationId xmlns:a16="http://schemas.microsoft.com/office/drawing/2014/main" id="{988394A2-EAAD-4189-B567-FF81A3457B83}"/>
+                <a16:creationId xmlns:a16="http://schemas.microsoft.com/office/drawing/2014/main" id="{BD2D092A-6913-499A-BA91-0F599E9786FC}"/>
               </a:ext>
             </a:extLst>
           </p:cNvPr>
@@ -5436,7 +5436,7 @@
           <p:cNvPr id="17" name="">
             <a:extLst xmlns:a="http://schemas.openxmlformats.org/drawingml/2006/main">
               <a:ext uri="{FF2B5EF4-FFF2-40B4-BE49-F238E27FC236}">
-                <a16:creationId xmlns:a16="http://schemas.microsoft.com/office/drawing/2014/main" id="{92DB103D-6F1E-4105-B8B8-52D7BB35B364}"/>
+                <a16:creationId xmlns:a16="http://schemas.microsoft.com/office/drawing/2014/main" id="{F2EC7E2A-7CB5-4FC3-B47B-877F6C9128A7}"/>
               </a:ext>
             </a:extLst>
           </p:cNvPr>
@@ -5493,7 +5493,7 @@
           <p:cNvPr id="18" name="">
             <a:extLst xmlns:a="http://schemas.openxmlformats.org/drawingml/2006/main">
               <a:ext uri="{FF2B5EF4-FFF2-40B4-BE49-F238E27FC236}">
-                <a16:creationId xmlns:a16="http://schemas.microsoft.com/office/drawing/2014/main" id="{2006445D-1513-4439-B92F-95B3DDE89AEB}"/>
+                <a16:creationId xmlns:a16="http://schemas.microsoft.com/office/drawing/2014/main" id="{7AA139CF-C94A-4B2D-806B-D6D666B9B781}"/>
               </a:ext>
             </a:extLst>
           </p:cNvPr>
@@ -5523,7 +5523,7 @@
           <p:cNvPr id="19" name="">
             <a:extLst xmlns:a="http://schemas.openxmlformats.org/drawingml/2006/main">
               <a:ext uri="{FF2B5EF4-FFF2-40B4-BE49-F238E27FC236}">
-                <a16:creationId xmlns:a16="http://schemas.microsoft.com/office/drawing/2014/main" id="{2499DBAA-6A91-4856-B569-3637A77C2EB8}"/>
+                <a16:creationId xmlns:a16="http://schemas.microsoft.com/office/drawing/2014/main" id="{F541661E-334C-4337-9B13-517E30058A82}"/>
               </a:ext>
             </a:extLst>
           </p:cNvPr>
@@ -5580,7 +5580,7 @@
           <p:cNvPr id="20" name="">
             <a:extLst xmlns:a="http://schemas.openxmlformats.org/drawingml/2006/main">
               <a:ext uri="{FF2B5EF4-FFF2-40B4-BE49-F238E27FC236}">
-                <a16:creationId xmlns:a16="http://schemas.microsoft.com/office/drawing/2014/main" id="{0E1BF166-1CD3-4721-B059-24412225743E}"/>
+                <a16:creationId xmlns:a16="http://schemas.microsoft.com/office/drawing/2014/main" id="{C912FEA4-4C4F-4AB5-91E2-D7169F38A53C}"/>
               </a:ext>
             </a:extLst>
           </p:cNvPr>
@@ -5762,7 +5762,7 @@
           <p:cNvPr id="26" name="">
             <a:extLst xmlns:a="http://schemas.openxmlformats.org/drawingml/2006/main">
               <a:ext uri="{FF2B5EF4-FFF2-40B4-BE49-F238E27FC236}">
-                <a16:creationId xmlns:a16="http://schemas.microsoft.com/office/drawing/2014/main" id="{F88A9ECF-CD29-481F-8603-F31D02DD2102}"/>
+                <a16:creationId xmlns:a16="http://schemas.microsoft.com/office/drawing/2014/main" id="{DDCA4F16-44C2-4DE7-A601-A41E7170D6EF}"/>
               </a:ext>
             </a:extLst>
           </p:cNvPr>
@@ -5819,7 +5819,7 @@
           <p:cNvPr id="27" name="">
             <a:extLst xmlns:a="http://schemas.openxmlformats.org/drawingml/2006/main">
               <a:ext uri="{FF2B5EF4-FFF2-40B4-BE49-F238E27FC236}">
-                <a16:creationId xmlns:a16="http://schemas.microsoft.com/office/drawing/2014/main" id="{4BCC1522-CB19-4306-96E4-8298519B1A20}"/>
+                <a16:creationId xmlns:a16="http://schemas.microsoft.com/office/drawing/2014/main" id="{82D7F963-EEC4-435F-A00E-770EECF4E575}"/>
               </a:ext>
             </a:extLst>
           </p:cNvPr>
@@ -5874,7 +5874,7 @@
     </p:spTree>
     <p:extLst>
       <p:ext uri="{BB962C8B-B14F-4D97-AF65-F5344CB8AC3E}">
-        <p14:creationId xmlns:p14="http://schemas.microsoft.com/office/powerpoint/2010/main" val="190583110"/>
+        <p14:creationId xmlns:p14="http://schemas.microsoft.com/office/powerpoint/2010/main" val="578185196"/>
       </p:ext>
     </p:extLst>
   </p:cSld>
@@ -5905,7 +5905,7 @@
           <p:cNvPr id="12" name="">
             <a:extLst xmlns:a="http://schemas.openxmlformats.org/drawingml/2006/main">
               <a:ext uri="{FF2B5EF4-FFF2-40B4-BE49-F238E27FC236}">
-                <a16:creationId xmlns:a16="http://schemas.microsoft.com/office/drawing/2014/main" id="{3A28B827-F98F-46BD-BA9D-20B9A7F3B16A}"/>
+                <a16:creationId xmlns:a16="http://schemas.microsoft.com/office/drawing/2014/main" id="{B54C9EA7-94E4-4AEE-8600-5A84F55F9220}"/>
               </a:ext>
             </a:extLst>
           </p:cNvPr>
@@ -5962,7 +5962,7 @@
           <p:cNvPr id="2" name="">
             <a:extLst xmlns:a="http://schemas.openxmlformats.org/drawingml/2006/main">
               <a:ext uri="{FF2B5EF4-FFF2-40B4-BE49-F238E27FC236}">
-                <a16:creationId xmlns:a16="http://schemas.microsoft.com/office/drawing/2014/main" id="{C7133921-FB52-4744-BAF5-7A52F0975FF4}"/>
+                <a16:creationId xmlns:a16="http://schemas.microsoft.com/office/drawing/2014/main" id="{4370E27D-A423-4D5A-BF41-35F1A99028C1}"/>
               </a:ext>
             </a:extLst>
           </p:cNvPr>
@@ -6019,7 +6019,7 @@
           <p:cNvPr id="3" name="">
             <a:extLst xmlns:a="http://schemas.openxmlformats.org/drawingml/2006/main">
               <a:ext uri="{FF2B5EF4-FFF2-40B4-BE49-F238E27FC236}">
-                <a16:creationId xmlns:a16="http://schemas.microsoft.com/office/drawing/2014/main" id="{D9F7C0A1-335D-43BA-B0F7-F7E1CEB22131}"/>
+                <a16:creationId xmlns:a16="http://schemas.microsoft.com/office/drawing/2014/main" id="{0A512567-3BAD-47F6-B0FB-8877038D8468}"/>
               </a:ext>
             </a:extLst>
           </p:cNvPr>
@@ -6076,7 +6076,7 @@
           <p:cNvPr id="4" name="">
             <a:extLst xmlns:a="http://schemas.openxmlformats.org/drawingml/2006/main">
               <a:ext uri="{FF2B5EF4-FFF2-40B4-BE49-F238E27FC236}">
-                <a16:creationId xmlns:a16="http://schemas.microsoft.com/office/drawing/2014/main" id="{69A67266-4925-498A-B49E-D9160CDCAD4C}"/>
+                <a16:creationId xmlns:a16="http://schemas.microsoft.com/office/drawing/2014/main" id="{B83C4E07-099E-4E5F-B476-251ACE6488C4}"/>
               </a:ext>
             </a:extLst>
           </p:cNvPr>
@@ -6156,7 +6156,7 @@
           <p:cNvPr id="5" name="">
             <a:extLst xmlns:a="http://schemas.openxmlformats.org/drawingml/2006/main">
               <a:ext uri="{FF2B5EF4-FFF2-40B4-BE49-F238E27FC236}">
-                <a16:creationId xmlns:a16="http://schemas.microsoft.com/office/drawing/2014/main" id="{DD8EA9B3-07A7-4777-88E8-183B93680294}"/>
+                <a16:creationId xmlns:a16="http://schemas.microsoft.com/office/drawing/2014/main" id="{930BEF53-9578-4CBB-92E2-DF7135C3A07E}"/>
               </a:ext>
             </a:extLst>
           </p:cNvPr>
@@ -6213,7 +6213,7 @@
           <p:cNvPr id="6" name="">
             <a:extLst xmlns:a="http://schemas.openxmlformats.org/drawingml/2006/main">
               <a:ext uri="{FF2B5EF4-FFF2-40B4-BE49-F238E27FC236}">
-                <a16:creationId xmlns:a16="http://schemas.microsoft.com/office/drawing/2014/main" id="{164EB21D-27E4-4AF9-BE10-B9BD8561167F}"/>
+                <a16:creationId xmlns:a16="http://schemas.microsoft.com/office/drawing/2014/main" id="{2C8EFADE-4E68-4589-823F-C9456AD26F17}"/>
               </a:ext>
             </a:extLst>
           </p:cNvPr>
@@ -6293,7 +6293,7 @@
           <p:cNvPr id="7" name="">
             <a:extLst xmlns:a="http://schemas.openxmlformats.org/drawingml/2006/main">
               <a:ext uri="{FF2B5EF4-FFF2-40B4-BE49-F238E27FC236}">
-                <a16:creationId xmlns:a16="http://schemas.microsoft.com/office/drawing/2014/main" id="{18077B7F-DC92-4F18-895B-7DF2A5110C5A}"/>
+                <a16:creationId xmlns:a16="http://schemas.microsoft.com/office/drawing/2014/main" id="{430A9100-3FA5-4E8A-8058-3DD0A452DFFE}"/>
               </a:ext>
             </a:extLst>
           </p:cNvPr>
@@ -6350,7 +6350,7 @@
           <p:cNvPr id="8" name="">
             <a:extLst xmlns:a="http://schemas.openxmlformats.org/drawingml/2006/main">
               <a:ext uri="{FF2B5EF4-FFF2-40B4-BE49-F238E27FC236}">
-                <a16:creationId xmlns:a16="http://schemas.microsoft.com/office/drawing/2014/main" id="{AFE0100A-0B0A-43AC-81D1-FEF45C5542B4}"/>
+                <a16:creationId xmlns:a16="http://schemas.microsoft.com/office/drawing/2014/main" id="{5A66786A-6808-4741-A76F-65CAED880263}"/>
               </a:ext>
             </a:extLst>
           </p:cNvPr>
@@ -6430,7 +6430,7 @@
           <p:cNvPr id="9" name="">
             <a:extLst xmlns:a="http://schemas.openxmlformats.org/drawingml/2006/main">
               <a:ext uri="{FF2B5EF4-FFF2-40B4-BE49-F238E27FC236}">
-                <a16:creationId xmlns:a16="http://schemas.microsoft.com/office/drawing/2014/main" id="{07D2D2DA-9140-4A27-B55C-A74E3A48BD80}"/>
+                <a16:creationId xmlns:a16="http://schemas.microsoft.com/office/drawing/2014/main" id="{321FC7CA-3169-4E98-BD74-0350EE39326A}"/>
               </a:ext>
             </a:extLst>
           </p:cNvPr>
@@ -6487,7 +6487,7 @@
           <p:cNvPr id="10" name="">
             <a:extLst xmlns:a="http://schemas.openxmlformats.org/drawingml/2006/main">
               <a:ext uri="{FF2B5EF4-FFF2-40B4-BE49-F238E27FC236}">
-                <a16:creationId xmlns:a16="http://schemas.microsoft.com/office/drawing/2014/main" id="{F3739954-86BC-494D-BC91-F391347B1567}"/>
+                <a16:creationId xmlns:a16="http://schemas.microsoft.com/office/drawing/2014/main" id="{9576AC8D-4D77-4FB0-BF5A-7940ABD4973A}"/>
               </a:ext>
             </a:extLst>
           </p:cNvPr>
@@ -6567,7 +6567,7 @@
           <p:cNvPr id="11" name="">
             <a:extLst xmlns:a="http://schemas.openxmlformats.org/drawingml/2006/main">
               <a:ext uri="{FF2B5EF4-FFF2-40B4-BE49-F238E27FC236}">
-                <a16:creationId xmlns:a16="http://schemas.microsoft.com/office/drawing/2014/main" id="{13529BC6-E058-454B-9B1D-AA5AD2ED8BC0}"/>
+                <a16:creationId xmlns:a16="http://schemas.microsoft.com/office/drawing/2014/main" id="{6781EB34-74B9-452E-98A0-65F19859A989}"/>
               </a:ext>
             </a:extLst>
           </p:cNvPr>
@@ -6622,7 +6622,7 @@
     </p:spTree>
     <p:extLst>
       <p:ext uri="{BB962C8B-B14F-4D97-AF65-F5344CB8AC3E}">
-        <p14:creationId xmlns:p14="http://schemas.microsoft.com/office/powerpoint/2010/main" val="657535105"/>
+        <p14:creationId xmlns:p14="http://schemas.microsoft.com/office/powerpoint/2010/main" val="743479983"/>
       </p:ext>
     </p:extLst>
   </p:cSld>
@@ -6653,7 +6653,7 @@
           <p:cNvPr id="9" name="">
             <a:extLst xmlns:a="http://schemas.openxmlformats.org/drawingml/2006/main">
               <a:ext uri="{FF2B5EF4-FFF2-40B4-BE49-F238E27FC236}">
-                <a16:creationId xmlns:a16="http://schemas.microsoft.com/office/drawing/2014/main" id="{5F4FC010-EE5E-47ED-91E8-0997868E3C9E}"/>
+                <a16:creationId xmlns:a16="http://schemas.microsoft.com/office/drawing/2014/main" id="{6A90902E-8FCA-4E14-8FD9-95365B0B81CF}"/>
               </a:ext>
             </a:extLst>
           </p:cNvPr>
@@ -6710,7 +6710,7 @@
           <p:cNvPr id="2" name="">
             <a:extLst xmlns:a="http://schemas.openxmlformats.org/drawingml/2006/main">
               <a:ext uri="{FF2B5EF4-FFF2-40B4-BE49-F238E27FC236}">
-                <a16:creationId xmlns:a16="http://schemas.microsoft.com/office/drawing/2014/main" id="{6FADB587-7949-4809-80E1-3E3DE0A71205}"/>
+                <a16:creationId xmlns:a16="http://schemas.microsoft.com/office/drawing/2014/main" id="{54B7843F-3A8C-4F5D-A362-A37C099A9C97}"/>
               </a:ext>
             </a:extLst>
           </p:cNvPr>
@@ -6767,7 +6767,7 @@
           <p:cNvPr id="3" name="">
             <a:extLst xmlns:a="http://schemas.openxmlformats.org/drawingml/2006/main">
               <a:ext uri="{FF2B5EF4-FFF2-40B4-BE49-F238E27FC236}">
-                <a16:creationId xmlns:a16="http://schemas.microsoft.com/office/drawing/2014/main" id="{B52D0821-6171-4AB4-999C-5672895C2FB8}"/>
+                <a16:creationId xmlns:a16="http://schemas.microsoft.com/office/drawing/2014/main" id="{FF207D99-F09A-4FD7-8AC2-175C9C82DEB0}"/>
               </a:ext>
             </a:extLst>
           </p:cNvPr>
@@ -6824,7 +6824,7 @@
           <p:cNvPr id="4" name="">
             <a:extLst xmlns:a="http://schemas.openxmlformats.org/drawingml/2006/main">
               <a:ext uri="{FF2B5EF4-FFF2-40B4-BE49-F238E27FC236}">
-                <a16:creationId xmlns:a16="http://schemas.microsoft.com/office/drawing/2014/main" id="{4031E4E6-D7CB-4720-B495-293D2942C82A}"/>
+                <a16:creationId xmlns:a16="http://schemas.microsoft.com/office/drawing/2014/main" id="{35CE9F0D-5B58-46DB-B26B-36BCBCBFC34B}"/>
               </a:ext>
             </a:extLst>
           </p:cNvPr>
@@ -6904,7 +6904,7 @@
           <p:cNvPr id="5" name="">
             <a:extLst xmlns:a="http://schemas.openxmlformats.org/drawingml/2006/main">
               <a:ext uri="{FF2B5EF4-FFF2-40B4-BE49-F238E27FC236}">
-                <a16:creationId xmlns:a16="http://schemas.microsoft.com/office/drawing/2014/main" id="{E94CEDD3-B0D1-4F6F-AB30-AA30158CF7F5}"/>
+                <a16:creationId xmlns:a16="http://schemas.microsoft.com/office/drawing/2014/main" id="{56F57177-EBEE-49C5-91C1-191A1DD905FE}"/>
               </a:ext>
             </a:extLst>
           </p:cNvPr>
@@ -6984,7 +6984,7 @@
           <p:cNvPr id="6" name="">
             <a:extLst xmlns:a="http://schemas.openxmlformats.org/drawingml/2006/main">
               <a:ext uri="{FF2B5EF4-FFF2-40B4-BE49-F238E27FC236}">
-                <a16:creationId xmlns:a16="http://schemas.microsoft.com/office/drawing/2014/main" id="{D8A6C2C4-180E-4377-9F25-E2F3337BE190}"/>
+                <a16:creationId xmlns:a16="http://schemas.microsoft.com/office/drawing/2014/main" id="{BFB2F1A4-0D55-47E3-B5A3-0C1BF1D28D52}"/>
               </a:ext>
             </a:extLst>
           </p:cNvPr>
@@ -7064,7 +7064,7 @@
           <p:cNvPr id="7" name="">
             <a:extLst xmlns:a="http://schemas.openxmlformats.org/drawingml/2006/main">
               <a:ext uri="{FF2B5EF4-FFF2-40B4-BE49-F238E27FC236}">
-                <a16:creationId xmlns:a16="http://schemas.microsoft.com/office/drawing/2014/main" id="{872570EB-CEB2-493F-AC98-93DA1967875F}"/>
+                <a16:creationId xmlns:a16="http://schemas.microsoft.com/office/drawing/2014/main" id="{B4537431-7BA5-4382-8F36-88DFE1F89566}"/>
               </a:ext>
             </a:extLst>
           </p:cNvPr>
@@ -7190,7 +7190,7 @@
           <p:cNvPr id="8" name="">
             <a:extLst xmlns:a="http://schemas.openxmlformats.org/drawingml/2006/main">
               <a:ext uri="{FF2B5EF4-FFF2-40B4-BE49-F238E27FC236}">
-                <a16:creationId xmlns:a16="http://schemas.microsoft.com/office/drawing/2014/main" id="{18F83579-D5B6-46E3-8ADB-511D737083C0}"/>
+                <a16:creationId xmlns:a16="http://schemas.microsoft.com/office/drawing/2014/main" id="{0F924302-1D8E-4E3F-A7EB-4A72E8821B00}"/>
               </a:ext>
             </a:extLst>
           </p:cNvPr>
@@ -7245,7 +7245,7 @@
     </p:spTree>
     <p:extLst>
       <p:ext uri="{BB962C8B-B14F-4D97-AF65-F5344CB8AC3E}">
-        <p14:creationId xmlns:p14="http://schemas.microsoft.com/office/powerpoint/2010/main" val="620461584"/>
+        <p14:creationId xmlns:p14="http://schemas.microsoft.com/office/powerpoint/2010/main" val="1765563341"/>
       </p:ext>
     </p:extLst>
   </p:cSld>
@@ -7273,10 +7273,10 @@
       </p:grpSpPr>
       <p:sp>
         <p:nvSpPr>
-          <p:cNvPr id="13" name="">
-            <a:extLst xmlns:a="http://schemas.openxmlformats.org/drawingml/2006/main">
-              <a:ext uri="{FF2B5EF4-FFF2-40B4-BE49-F238E27FC236}">
-                <a16:creationId xmlns:a16="http://schemas.microsoft.com/office/drawing/2014/main" id="{54BE1543-BA94-4800-8677-1A291B19B39B}"/>
+          <p:cNvPr id="14" name="">
+            <a:extLst xmlns:a="http://schemas.openxmlformats.org/drawingml/2006/main">
+              <a:ext uri="{FF2B5EF4-FFF2-40B4-BE49-F238E27FC236}">
+                <a16:creationId xmlns:a16="http://schemas.microsoft.com/office/drawing/2014/main" id="{91242D2F-D5A2-46F4-9376-C1D3F753A06B}"/>
               </a:ext>
             </a:extLst>
           </p:cNvPr>
@@ -7333,7 +7333,7 @@
           <p:cNvPr id="2" name="">
             <a:extLst xmlns:a="http://schemas.openxmlformats.org/drawingml/2006/main">
               <a:ext uri="{FF2B5EF4-FFF2-40B4-BE49-F238E27FC236}">
-                <a16:creationId xmlns:a16="http://schemas.microsoft.com/office/drawing/2014/main" id="{DB7DF4A1-8B79-43DD-8FEC-1D389788624A}"/>
+                <a16:creationId xmlns:a16="http://schemas.microsoft.com/office/drawing/2014/main" id="{58BE0F42-4E8F-4C8C-A2B4-DFA07E69822E}"/>
               </a:ext>
             </a:extLst>
           </p:cNvPr>
@@ -7390,7 +7390,7 @@
           <p:cNvPr id="3" name="">
             <a:extLst xmlns:a="http://schemas.openxmlformats.org/drawingml/2006/main">
               <a:ext uri="{FF2B5EF4-FFF2-40B4-BE49-F238E27FC236}">
-                <a16:creationId xmlns:a16="http://schemas.microsoft.com/office/drawing/2014/main" id="{A2F56333-A9C8-4482-9B45-954B474076CA}"/>
+                <a16:creationId xmlns:a16="http://schemas.microsoft.com/office/drawing/2014/main" id="{316AAB96-C9D7-49C9-97E2-402250884B53}"/>
               </a:ext>
             </a:extLst>
           </p:cNvPr>
@@ -7447,7 +7447,7 @@
           <p:cNvPr id="4" name="">
             <a:extLst xmlns:a="http://schemas.openxmlformats.org/drawingml/2006/main">
               <a:ext uri="{FF2B5EF4-FFF2-40B4-BE49-F238E27FC236}">
-                <a16:creationId xmlns:a16="http://schemas.microsoft.com/office/drawing/2014/main" id="{96D81DF6-E62B-4F51-AD3E-57C9A3F8E028}"/>
+                <a16:creationId xmlns:a16="http://schemas.microsoft.com/office/drawing/2014/main" id="{2949EBFD-8392-40DA-B283-63272F30AD1B}"/>
               </a:ext>
             </a:extLst>
           </p:cNvPr>
@@ -7504,7 +7504,7 @@
           <p:cNvPr id="5" name="">
             <a:extLst xmlns:a="http://schemas.openxmlformats.org/drawingml/2006/main">
               <a:ext uri="{FF2B5EF4-FFF2-40B4-BE49-F238E27FC236}">
-                <a16:creationId xmlns:a16="http://schemas.microsoft.com/office/drawing/2014/main" id="{CF99236D-314E-417E-A1BA-D335E37C75FA}"/>
+                <a16:creationId xmlns:a16="http://schemas.microsoft.com/office/drawing/2014/main" id="{C39226C9-1962-4056-8599-B7807C649C00}"/>
               </a:ext>
             </a:extLst>
           </p:cNvPr>
@@ -7561,7 +7561,7 @@
           <p:cNvPr id="6" name="">
             <a:extLst xmlns:a="http://schemas.openxmlformats.org/drawingml/2006/main">
               <a:ext uri="{FF2B5EF4-FFF2-40B4-BE49-F238E27FC236}">
-                <a16:creationId xmlns:a16="http://schemas.microsoft.com/office/drawing/2014/main" id="{639121AB-FF8F-4145-8DB0-6D0023851C4A}"/>
+                <a16:creationId xmlns:a16="http://schemas.microsoft.com/office/drawing/2014/main" id="{520C39D3-2D01-42D5-A274-868271E81FDA}"/>
               </a:ext>
             </a:extLst>
           </p:cNvPr>
@@ -7618,7 +7618,7 @@
           <p:cNvPr id="7" name="">
             <a:extLst xmlns:a="http://schemas.openxmlformats.org/drawingml/2006/main">
               <a:ext uri="{FF2B5EF4-FFF2-40B4-BE49-F238E27FC236}">
-                <a16:creationId xmlns:a16="http://schemas.microsoft.com/office/drawing/2014/main" id="{917FE2B8-6729-44F6-A829-4BBF0215D619}"/>
+                <a16:creationId xmlns:a16="http://schemas.microsoft.com/office/drawing/2014/main" id="{33C61911-A96E-4640-B598-40BEE39A3FA6}"/>
               </a:ext>
             </a:extLst>
           </p:cNvPr>
@@ -7675,7 +7675,7 @@
           <p:cNvPr id="8" name="">
             <a:extLst xmlns:a="http://schemas.openxmlformats.org/drawingml/2006/main">
               <a:ext uri="{FF2B5EF4-FFF2-40B4-BE49-F238E27FC236}">
-                <a16:creationId xmlns:a16="http://schemas.microsoft.com/office/drawing/2014/main" id="{ECDB1857-5EE1-4CB1-9F0E-E19B682C5C17}"/>
+                <a16:creationId xmlns:a16="http://schemas.microsoft.com/office/drawing/2014/main" id="{1936639D-670C-4DB9-8FF4-D5D727AD94D4}"/>
               </a:ext>
             </a:extLst>
           </p:cNvPr>
@@ -7732,7 +7732,7 @@
           <p:cNvPr id="9" name="">
             <a:extLst xmlns:a="http://schemas.openxmlformats.org/drawingml/2006/main">
               <a:ext uri="{FF2B5EF4-FFF2-40B4-BE49-F238E27FC236}">
-                <a16:creationId xmlns:a16="http://schemas.microsoft.com/office/drawing/2014/main" id="{B0AF7553-A3B1-4EE4-936C-328F8E0D720B}"/>
+                <a16:creationId xmlns:a16="http://schemas.microsoft.com/office/drawing/2014/main" id="{9B056483-582D-4F1D-BC72-F55C5FE5D7F7}"/>
               </a:ext>
             </a:extLst>
           </p:cNvPr>
@@ -7789,7 +7789,7 @@
           <p:cNvPr id="10" name="">
             <a:extLst xmlns:a="http://schemas.openxmlformats.org/drawingml/2006/main">
               <a:ext uri="{FF2B5EF4-FFF2-40B4-BE49-F238E27FC236}">
-                <a16:creationId xmlns:a16="http://schemas.microsoft.com/office/drawing/2014/main" id="{499CEFF3-B6E9-4842-B0CC-ECC4B154586B}"/>
+                <a16:creationId xmlns:a16="http://schemas.microsoft.com/office/drawing/2014/main" id="{12EF79F7-51D8-4BDF-8524-EB8560E912AC}"/>
               </a:ext>
             </a:extLst>
           </p:cNvPr>
@@ -7836,7 +7836,7 @@
                 <a:ea typeface="Helvetica Neue"/>
                 <a:cs typeface="Helvetica Neue"/>
               </a:rPr>
-              <a:t>Record an actual CLI run; browser UI demo remains pending.</a:t>
+              <a:t>CLI demo available. Browser UI recording pending.</a:t>
             </a:r>
           </a:p>
         </p:txBody>
@@ -7846,9 +7846,69 @@
           <p:cNvPr id="11" name="">
             <a:extLst xmlns:a="http://schemas.openxmlformats.org/drawingml/2006/main">
               <a:ext uri="{FF2B5EF4-FFF2-40B4-BE49-F238E27FC236}">
-                <a16:creationId xmlns:a16="http://schemas.microsoft.com/office/drawing/2014/main" id="{398E0DBC-95AF-4699-82D9-45666662F387}"/>
-              </a:ext>
-            </a:extLst>
+                <a16:creationId xmlns:a16="http://schemas.microsoft.com/office/drawing/2014/main" id="{EE0A3999-1FD9-4A35-818D-E57D11847947}"/>
+              </a:ext>
+            </a:extLst>
+            <ns1:hlinkClick xmlns:ns1="http://schemas.openxmlformats.org/drawingml/2006/main" xmlns:ns2="http://schemas.openxmlformats.org/officeDocument/2006/relationships" ns2:id="rIdEvidenceLink1" tooltip="https://github.com/alexsolonsky/evidencedesk/blob/main/demo/evidencedesk-cli-demo.mp4"/>
+          </p:cNvPr>
+          <p:cNvSpPr>
+            <a:spLocks xmlns:a="http://schemas.openxmlformats.org/drawingml/2006/main" noGrp="1"/>
+          </p:cNvSpPr>
+          <p:nvPr/>
+        </p:nvSpPr>
+        <p:spPr>
+          <a:xfrm xmlns:a="http://schemas.openxmlformats.org/drawingml/2006/main">
+            <a:off x="704850" y="5162550"/>
+            <a:ext cx="10763250" cy="361950"/>
+          </a:xfrm>
+          <a:prstGeom xmlns:a="http://schemas.openxmlformats.org/drawingml/2006/main" prst="rect">
+            <a:avLst/>
+          </a:prstGeom>
+          <a:noFill xmlns:a="http://schemas.openxmlformats.org/drawingml/2006/main"/>
+          <a:ln xmlns:a="http://schemas.openxmlformats.org/drawingml/2006/main" w="0">
+            <a:noFill/>
+          </a:ln>
+        </p:spPr>
+        <p:txBody>
+          <a:bodyPr xmlns:a="http://schemas.openxmlformats.org/drawingml/2006/main" lIns="0" tIns="0" rIns="0" bIns="0" anchor="t">
+            <a:noAutofit/>
+          </a:bodyPr>
+          <a:lstStyle xmlns:a="http://schemas.openxmlformats.org/drawingml/2006/main"/>
+          <a:p xmlns:a="http://schemas.openxmlformats.org/drawingml/2006/main">
+            <a:pPr algn="l">
+              <a:defRPr sz="1875" b="1">
+                <a:solidFill>
+                  <a:srgbClr val="AEBCC7"/>
+                </a:solidFill>
+                <a:latin typeface="Helvetica Neue"/>
+                <a:ea typeface="Helvetica Neue"/>
+                <a:cs typeface="Helvetica Neue"/>
+              </a:defRPr>
+            </a:pPr>
+            <a:r>
+              <a:rPr sz="1875" b="1">
+                <a:solidFill>
+                  <a:srgbClr val="AEBCC7"/>
+                </a:solidFill>
+                <a:latin typeface="Helvetica Neue"/>
+                <a:ea typeface="Helvetica Neue"/>
+                <a:cs typeface="Helvetica Neue"/>
+                <a:hlinkClick xmlns:ns0="http://schemas.openxmlformats.org/officeDocument/2006/relationships" ns0:id="rIdEvidenceLink1" tooltip="https://github.com/alexsolonsky/evidencedesk/blob/main/demo/evidencedesk-cli-demo.mp4"/>
+              </a:rPr>
+              <a:t>View CLI demonstration (3:40)</a:t>
+            </a:r>
+          </a:p>
+        </p:txBody>
+      </p:sp>
+      <p:sp>
+        <p:nvSpPr>
+          <p:cNvPr id="12" name="">
+            <a:extLst xmlns:a="http://schemas.openxmlformats.org/drawingml/2006/main">
+              <a:ext uri="{FF2B5EF4-FFF2-40B4-BE49-F238E27FC236}">
+                <a16:creationId xmlns:a16="http://schemas.microsoft.com/office/drawing/2014/main" id="{649ACE81-9ACD-454B-B298-854B61B45745}"/>
+              </a:ext>
+            </a:extLst>
+            <ns4:hlinkClick xmlns:ns4="http://schemas.openxmlformats.org/drawingml/2006/main" xmlns:ns5="http://schemas.openxmlformats.org/officeDocument/2006/relationships" ns5:id="rIdEvidenceLink2" tooltip="https://github.com/alexsolonsky/evidencedesk"/>
           </p:cNvPr>
           <p:cNvSpPr>
             <a:spLocks xmlns:a="http://schemas.openxmlformats.org/drawingml/2006/main" noGrp="1"/>
@@ -7892,6 +7952,7 @@
                 <a:latin typeface="Helvetica Neue"/>
                 <a:ea typeface="Helvetica Neue"/>
                 <a:cs typeface="Helvetica Neue"/>
+                <a:hlinkClick xmlns:ns3="http://schemas.openxmlformats.org/officeDocument/2006/relationships" ns3:id="rIdEvidenceLink2" tooltip="https://github.com/alexsolonsky/evidencedesk"/>
               </a:rPr>
               <a:t>Public source: github.com/alexsolonsky/evidencedesk</a:t>
             </a:r>
@@ -7900,10 +7961,10 @@
       </p:sp>
       <p:sp>
         <p:nvSpPr>
-          <p:cNvPr id="12" name="">
-            <a:extLst xmlns:a="http://schemas.openxmlformats.org/drawingml/2006/main">
-              <a:ext uri="{FF2B5EF4-FFF2-40B4-BE49-F238E27FC236}">
-                <a16:creationId xmlns:a16="http://schemas.microsoft.com/office/drawing/2014/main" id="{CA18BB72-5AC6-43FE-B139-60E9B9720156}"/>
+          <p:cNvPr id="13" name="">
+            <a:extLst xmlns:a="http://schemas.openxmlformats.org/drawingml/2006/main">
+              <a:ext uri="{FF2B5EF4-FFF2-40B4-BE49-F238E27FC236}">
+                <a16:creationId xmlns:a16="http://schemas.microsoft.com/office/drawing/2014/main" id="{34B28A15-2590-4833-B90D-0ED45DB4D69D}"/>
               </a:ext>
             </a:extLst>
           </p:cNvPr>
@@ -7958,7 +8019,7 @@
     </p:spTree>
     <p:extLst>
       <p:ext uri="{BB962C8B-B14F-4D97-AF65-F5344CB8AC3E}">
-        <p14:creationId xmlns:p14="http://schemas.microsoft.com/office/powerpoint/2010/main" val="1383833250"/>
+        <p14:creationId xmlns:p14="http://schemas.microsoft.com/office/powerpoint/2010/main" val="1657605198"/>
       </p:ext>
     </p:extLst>
   </p:cSld>

</xml_diff>